<commit_message>
docs: refresh verified release presentation
</commit_message>
<xml_diff>
--- a/submission-assets/CommerceOS-ACT-III-Pitch.pptx
+++ b/submission-assets/CommerceOS-ACT-III-Pitch.pptx
@@ -1037,7 +1037,7 @@
           <a:p>
             <a:r>
               <a:rPr lang="en-US" dirty="0"/>
-              <a:t>Summarize the release evidence. The local CRLF checkout makes the aggregate Prettier byte check noisy; CI on the pull request is the authoritative LF-normalized format and contract check.</a:t>
+              <a:t>Summarize the release evidence. Public CI passed quality and browser-smoke on commit 3075513. The deployed application preserves production MarginLeak restrictions.</a:t>
             </a:r>
             <a:endParaRPr lang="en-US" dirty="0"/>
           </a:p>
@@ -1125,7 +1125,7 @@
           <a:p>
             <a:r>
               <a:rPr lang="en-US" dirty="0"/>
-              <a:t>Close with the exact asks: organizer entitlement for AMD, and operator approval for license, publication, deployment, and final submission.</a:t>
+              <a:t>Close with the exact remaining asks: organizer entitlement for AMD and the operator's reserved final submission confirmation.</a:t>
             </a:r>
             <a:endParaRPr lang="en-US" dirty="0"/>
           </a:p>
@@ -5513,7 +5513,7 @@
                 <a:ea typeface="Calibri" pitchFamily="34" charset="-122"/>
                 <a:cs typeface="Calibri" pitchFamily="34" charset="-120"/>
               </a:rPr>
-              <a:t>Source: f98264d · all figures are automated checks from Mission 016</a:t>
+              <a:t>Private source f13f7de · public release 3075513 · automated checks from Mission 017</a:t>
             </a:r>
             <a:endParaRPr lang="en-US" sz="1400" dirty="0"/>
           </a:p>
@@ -5894,7 +5894,7 @@
                 <a:ea typeface="Arial" pitchFamily="34" charset="-122"/>
                 <a:cs typeface="Arial" pitchFamily="34" charset="-120"/>
               </a:rPr>
-              <a:t>270</a:t>
+              <a:t>173</a:t>
             </a:r>
             <a:endParaRPr lang="en-US" sz="4200" dirty="0"/>
           </a:p>
@@ -5933,7 +5933,7 @@
                 <a:ea typeface="Calibri" pitchFamily="34" charset="-122"/>
                 <a:cs typeface="Calibri" pitchFamily="34" charset="-120"/>
               </a:rPr>
-              <a:t>Git-history blobs scanned</a:t>
+              <a:t>public files scanned</a:t>
             </a:r>
             <a:endParaRPr lang="en-US" sz="1350" dirty="0"/>
           </a:p>
@@ -6389,7 +6389,7 @@
                 <a:ea typeface="Calibri" pitchFamily="34" charset="-122"/>
                 <a:cs typeface="Calibri" pitchFamily="34" charset="-120"/>
               </a:rPr>
-              <a:t>Release caveat: root project license selection remains required before public publication.</a:t>
+              <a:t>MIT-licensed public release and production deployment verified on October 18, 2026.</a:t>
             </a:r>
             <a:endParaRPr lang="en-US" sz="1250" dirty="0"/>
           </a:p>
@@ -6544,7 +6544,7 @@
                 <a:ea typeface="Calibri" pitchFamily="34" charset="-122"/>
                 <a:cs typeface="Calibri" pitchFamily="34" charset="-120"/>
               </a:rPr>
-              <a:t>The product package is prepared. Publication and AMD entitlement are the remaining external gates.</a:t>
+              <a:t>The public release is live. AMD entitlement and the operator's final Submit action remain unresolved.</a:t>
             </a:r>
             <a:endParaRPr lang="en-US" sz="1800" dirty="0"/>
           </a:p>
@@ -6644,7 +6644,7 @@
                 <a:ea typeface="Arial" pitchFamily="34" charset="-122"/>
                 <a:cs typeface="Arial" pitchFamily="34" charset="-120"/>
               </a:rPr>
-              <a:t>Prepared</a:t>
+              <a:t>Published</a:t>
             </a:r>
             <a:endParaRPr lang="en-US" sz="1700" dirty="0"/>
           </a:p>
@@ -6683,7 +6683,7 @@
                 <a:ea typeface="Calibri" pitchFamily="34" charset="-122"/>
                 <a:cs typeface="Calibri" pitchFamily="34" charset="-120"/>
               </a:rPr>
-              <a:t>README · submission copy · cover · slides/PDF · real-app video · audit · deployment handoff</a:t>
+              <a:t>MIT source · public repository · Vercel deployment · cover · slides/PDF · authentic video</a:t>
             </a:r>
             <a:endParaRPr lang="en-US" sz="1250" dirty="0"/>
           </a:p>
@@ -6783,7 +6783,7 @@
                 <a:ea typeface="Arial" pitchFamily="34" charset="-122"/>
                 <a:cs typeface="Arial" pitchFamily="34" charset="-120"/>
               </a:rPr>
-              <a:t>Operator approval</a:t>
+              <a:t>Operator action</a:t>
             </a:r>
             <a:endParaRPr lang="en-US" sz="1700" dirty="0"/>
           </a:p>
@@ -6822,7 +6822,7 @@
                 <a:ea typeface="Calibri" pitchFamily="34" charset="-122"/>
                 <a:cs typeface="Calibri" pitchFamily="34" charset="-120"/>
               </a:rPr>
-              <a:t>License · public repository · deployment · public uploads · final Submit</a:t>
+              <a:t>Review the completed event form and perform the reserved final Submit action.</a:t>
             </a:r>
             <a:endParaRPr lang="en-US" sz="1250" dirty="0"/>
           </a:p>

</xml_diff>

<commit_message>
fix: normalize release presentation package
</commit_message>
<xml_diff>
--- a/submission-assets/CommerceOS-ACT-III-Pitch.pptx
+++ b/submission-assets/CommerceOS-ACT-III-Pitch.pptx
@@ -4,6 +4,9 @@
   <p:sldMasterIdLst>
     <p:sldMasterId id="2147483648" r:id="rId1"/>
   </p:sldMasterIdLst>
+  <p:notesMasterIdLst>
+    <p:notesMasterId r:id="rId10"/>
+  </p:notesMasterIdLst>
   <p:sldIdLst>
     <p:sldId id="256" r:id="rId2"/>
     <p:sldId id="257" r:id="rId3"/>
@@ -14,9 +17,6 @@
     <p:sldId id="262" r:id="rId8"/>
     <p:sldId id="263" r:id="rId9"/>
   </p:sldIdLst>
-  <p:notesMasterIdLst>
-    <p:notesMasterId r:id="rId10"/>
-  </p:notesMasterIdLst>
   <p:sldSz cx="12192000" cy="6858000"/>
   <p:notesSz cx="6858000" cy="12192000"/>
   <p:defaultTextStyle>
@@ -111,6 +111,11 @@
       </a:defRPr>
     </a:lvl9pPr>
   </p:defaultTextStyle>
+  <p:extLst>
+    <p:ext uri="{EFAFB233-063F-42B5-8137-9DF3F51BA10A}">
+      <p15:sldGuideLst xmlns:p15="http://schemas.microsoft.com/office/powerpoint/2012/main"/>
+    </p:ext>
+  </p:extLst>
 </p:presentation>
 </file>
 
@@ -136,234 +141,10 @@
           <a:chExt cx="0" cy="0"/>
         </a:xfrm>
       </p:grpSpPr>
-      <p:sp>
-        <p:nvSpPr>
-          <p:cNvPr id="2" name="Header Placeholder 1"/>
-          <p:cNvSpPr>
-            <a:spLocks noGrp="1"/>
-          </p:cNvSpPr>
-          <p:nvPr>
-            <p:ph type="hdr" sz="quarter"/>
-          </p:nvPr>
-        </p:nvSpPr>
-        <p:spPr>
-          <a:xfrm>
-            <a:off x="0" y="0"/>
-            <a:ext cx="2971800" cy="458788"/>
-          </a:xfrm>
-          <a:prstGeom prst="rect">
-            <a:avLst/>
-          </a:prstGeom>
-        </p:spPr>
-        <p:txBody>
-          <a:bodyPr vert="horz" lIns="91440" tIns="45720" rIns="91440" bIns="45720" rtlCol="0"/>
-          <a:lstStyle>
-            <a:lvl1pPr algn="l">
-              <a:defRPr sz="1200"/>
-            </a:lvl1pPr>
-          </a:lstStyle>
-          <a:p>
-            <a:endParaRPr lang="en-US"/>
-          </a:p>
-        </p:txBody>
-      </p:sp>
-      <p:sp>
-        <p:nvSpPr>
-          <p:cNvPr id="3" name="Date Placeholder 2"/>
-          <p:cNvSpPr>
-            <a:spLocks noGrp="1"/>
-          </p:cNvSpPr>
-          <p:nvPr>
-            <p:ph type="dt" idx="1"/>
-          </p:nvPr>
-        </p:nvSpPr>
-        <p:spPr>
-          <a:xfrm>
-            <a:off x="3884613" y="0"/>
-            <a:ext cx="2971800" cy="458788"/>
-          </a:xfrm>
-          <a:prstGeom prst="rect">
-            <a:avLst/>
-          </a:prstGeom>
-        </p:spPr>
-        <p:txBody>
-          <a:bodyPr vert="horz" lIns="91440" tIns="45720" rIns="91440" bIns="45720" rtlCol="0"/>
-          <a:lstStyle>
-            <a:lvl1pPr algn="r">
-              <a:defRPr sz="1200"/>
-            </a:lvl1pPr>
-          </a:lstStyle>
-          <a:p>
-            <a:fld id="{5282F153-3F37-0F45-9E97-73ACFA13230C}" type="datetimeFigureOut">
-              <a:rPr lang="en-US"/>
-              <a:t>7/23/19</a:t>
-            </a:fld>
-            <a:endParaRPr lang="en-US"/>
-          </a:p>
-        </p:txBody>
-      </p:sp>
-      <p:sp>
-        <p:nvSpPr>
-          <p:cNvPr id="4" name="Slide Image Placeholder 3"/>
-          <p:cNvSpPr>
-            <a:spLocks noGrp="1" noRot="1" noChangeAspect="1"/>
-          </p:cNvSpPr>
-          <p:nvPr>
-            <p:ph type="sldImg" idx="2"/>
-          </p:nvPr>
-        </p:nvSpPr>
-        <p:spPr>
-          <a:xfrm>
-            <a:off x="685800" y="1143000"/>
-            <a:ext cx="5486400" cy="3086100"/>
-          </a:xfrm>
-          <a:prstGeom prst="rect">
-            <a:avLst/>
-          </a:prstGeom>
-          <a:noFill/>
-          <a:ln w="12700">
-            <a:solidFill>
-              <a:prstClr val="black"/>
-            </a:solidFill>
-          </a:ln>
-        </p:spPr>
-        <p:txBody>
-          <a:bodyPr vert="horz" lIns="91440" tIns="45720" rIns="91440" bIns="45720" rtlCol="0" anchor="ctr"/>
-          <a:lstStyle/>
-          <a:p>
-            <a:endParaRPr lang="en-US"/>
-          </a:p>
-        </p:txBody>
-      </p:sp>
-      <p:sp>
-        <p:nvSpPr>
-          <p:cNvPr id="5" name="Notes Placeholder 4"/>
-          <p:cNvSpPr>
-            <a:spLocks noGrp="1"/>
-          </p:cNvSpPr>
-          <p:nvPr>
-            <p:ph type="body" sz="quarter" idx="3"/>
-          </p:nvPr>
-        </p:nvSpPr>
-        <p:spPr>
-          <a:xfrm>
-            <a:off x="685800" y="4400550"/>
-            <a:ext cx="5486400" cy="3600450"/>
-          </a:xfrm>
-          <a:prstGeom prst="rect">
-            <a:avLst/>
-          </a:prstGeom>
-        </p:spPr>
-        <p:txBody>
-          <a:bodyPr vert="horz" lIns="91440" tIns="45720" rIns="91440" bIns="45720" rtlCol="0"/>
-          <a:lstStyle/>
-          <a:p>
-            <a:pPr lvl="0"/>
-            <a:r>
-              <a:rPr lang="en-US"/>
-              <a:t>Click to edit Master text styles</a:t>
-            </a:r>
-          </a:p>
-          <a:p>
-            <a:pPr lvl="1"/>
-            <a:r>
-              <a:rPr lang="en-US"/>
-              <a:t>Second level</a:t>
-            </a:r>
-          </a:p>
-          <a:p>
-            <a:pPr lvl="2"/>
-            <a:r>
-              <a:rPr lang="en-US"/>
-              <a:t>Third level</a:t>
-            </a:r>
-          </a:p>
-          <a:p>
-            <a:pPr lvl="3"/>
-            <a:r>
-              <a:rPr lang="en-US"/>
-              <a:t>Fourth level</a:t>
-            </a:r>
-          </a:p>
-          <a:p>
-            <a:pPr lvl="4"/>
-            <a:r>
-              <a:rPr lang="en-US"/>
-              <a:t>Fifth level</a:t>
-            </a:r>
-          </a:p>
-        </p:txBody>
-      </p:sp>
-      <p:sp>
-        <p:nvSpPr>
-          <p:cNvPr id="6" name="Footer Placeholder 5"/>
-          <p:cNvSpPr>
-            <a:spLocks noGrp="1"/>
-          </p:cNvSpPr>
-          <p:nvPr>
-            <p:ph type="ftr" sz="quarter" idx="4"/>
-          </p:nvPr>
-        </p:nvSpPr>
-        <p:spPr>
-          <a:xfrm>
-            <a:off x="0" y="8685213"/>
-            <a:ext cx="2971800" cy="458787"/>
-          </a:xfrm>
-          <a:prstGeom prst="rect">
-            <a:avLst/>
-          </a:prstGeom>
-        </p:spPr>
-        <p:txBody>
-          <a:bodyPr vert="horz" lIns="91440" tIns="45720" rIns="91440" bIns="45720" rtlCol="0" anchor="b"/>
-          <a:lstStyle>
-            <a:lvl1pPr algn="l">
-              <a:defRPr sz="1200"/>
-            </a:lvl1pPr>
-          </a:lstStyle>
-          <a:p>
-            <a:endParaRPr lang="en-US"/>
-          </a:p>
-        </p:txBody>
-      </p:sp>
-      <p:sp>
-        <p:nvSpPr>
-          <p:cNvPr id="7" name="Slide Number Placeholder 6"/>
-          <p:cNvSpPr>
-            <a:spLocks noGrp="1"/>
-          </p:cNvSpPr>
-          <p:nvPr>
-            <p:ph type="sldNum" sz="quarter" idx="5"/>
-          </p:nvPr>
-        </p:nvSpPr>
-        <p:spPr>
-          <a:xfrm>
-            <a:off x="3884613" y="8685213"/>
-            <a:ext cx="2971800" cy="458787"/>
-          </a:xfrm>
-          <a:prstGeom prst="rect">
-            <a:avLst/>
-          </a:prstGeom>
-        </p:spPr>
-        <p:txBody>
-          <a:bodyPr vert="horz" lIns="91440" tIns="45720" rIns="91440" bIns="45720" rtlCol="0" anchor="b"/>
-          <a:lstStyle>
-            <a:lvl1pPr algn="r">
-              <a:defRPr sz="1200"/>
-            </a:lvl1pPr>
-          </a:lstStyle>
-          <a:p>
-            <a:fld id="{CE5E9CC1-C706-0F49-92D6-E571CC5EEA8F}" type="slidenum">
-              <a:rPr lang="en-US"/>
-              <a:t>‹#›</a:t>
-            </a:fld>
-            <a:endParaRPr lang="en-US"/>
-          </a:p>
-        </p:txBody>
-      </p:sp>
     </p:spTree>
     <p:extLst>
       <p:ext uri="{BB962C8B-B14F-4D97-AF65-F5344CB8AC3E}">
-        <p14:creationId xmlns:p14="http://schemas.microsoft.com/office/powerpoint/2010/main" val="1024086991"/>
+        <p14:creationId xmlns:p14="http://schemas.microsoft.com/office/powerpoint/2010/main" val="1195716739"/>
       </p:ext>
     </p:extLst>
   </p:cSld>
@@ -511,7 +292,6 @@
               <a:rPr lang="en-US" dirty="0"/>
               <a:t>CommerceOS is a rule-first commerce control room. Deterministic rules own verdicts, money, and review gates. Live AMD inference is pending event entitlement and is not claimed in this deck.</a:t>
             </a:r>
-            <a:endParaRPr lang="en-US" dirty="0"/>
           </a:p>
         </p:txBody>
       </p:sp>
@@ -599,7 +379,6 @@
               <a:rPr lang="en-US" dirty="0"/>
               <a:t>Frame the problem around operational trust. CommerceOS is not another chat interface; it is a deterministic evidence and governance layer.</a:t>
             </a:r>
-            <a:endParaRPr lang="en-US" dirty="0"/>
           </a:p>
         </p:txBody>
       </p:sp>
@@ -687,7 +466,6 @@
               <a:rPr lang="en-US" dirty="0"/>
               <a:t>Show the at-risk result. Point out inventory, blocker, deadline, and readiness findings; then show the human-review flag and inference-offline truthfulness.</a:t>
             </a:r>
-            <a:endParaRPr lang="en-US" dirty="0"/>
           </a:p>
         </p:txBody>
       </p:sp>
@@ -775,7 +553,6 @@
               <a:rPr lang="en-US" dirty="0"/>
               <a:t>Walk through expected versus observed contribution margin and the category ledger. Emphasize that provisional and incomplete evidence never produces a confirmed leak amount.</a:t>
             </a:r>
-            <a:endParaRPr lang="en-US" dirty="0"/>
           </a:p>
         </p:txBody>
       </p:sp>
@@ -863,7 +640,6 @@
               <a:rPr lang="en-US" dirty="0"/>
               <a:t>Explain the order of operations. Evidence is validated, rules evaluate, review policy routes, provenance is attached, and only then can an optional model produce bounded advisory text.</a:t>
             </a:r>
-            <a:endParaRPr lang="en-US" dirty="0"/>
           </a:p>
         </p:txBody>
       </p:sp>
@@ -951,7 +727,6 @@
               <a:rPr lang="en-US" dirty="0"/>
               <a:t>Use this slide to answer trust and safety questions. Every uncertain state is explicit and production restrictions stay intact.</a:t>
             </a:r>
-            <a:endParaRPr lang="en-US" dirty="0"/>
           </a:p>
         </p:txBody>
       </p:sp>
@@ -1039,7 +814,6 @@
               <a:rPr lang="en-US" dirty="0"/>
               <a:t>Summarize the release evidence. Public CI passed quality and browser-smoke on commit 3075513. The deployed application preserves production MarginLeak restrictions.</a:t>
             </a:r>
-            <a:endParaRPr lang="en-US" dirty="0"/>
           </a:p>
         </p:txBody>
       </p:sp>
@@ -1127,7 +901,6 @@
               <a:rPr lang="en-US" dirty="0"/>
               <a:t>Close with the exact remaining asks: organizer entitlement for AMD and the operator's reserved final submission confirmation.</a:t>
             </a:r>
-            <a:endParaRPr lang="en-US" dirty="0"/>
           </a:p>
         </p:txBody>
       </p:sp>
@@ -1205,6 +978,7 @@
         <a:solidFill>
           <a:srgbClr val="F4F7FA"/>
         </a:solidFill>
+        <a:effectLst/>
       </p:bgPr>
     </p:bg>
     <p:spTree>
@@ -1242,7 +1016,7 @@
           <a:bodyPr wrap="square" lIns="0" tIns="0" rIns="0" bIns="0" rtlCol="0" anchor="ctr"/>
           <a:lstStyle/>
           <a:p>
-            <a:pPr indent="0" marL="0">
+            <a:pPr marL="0" indent="0">
               <a:buNone/>
             </a:pPr>
             <a:r>
@@ -1281,7 +1055,7 @@
           <a:bodyPr wrap="square" lIns="0" tIns="0" rIns="0" bIns="0" rtlCol="0" anchor="ctr"/>
           <a:lstStyle/>
           <a:p>
-            <a:pPr algn="r" indent="0" marL="0">
+            <a:pPr marL="0" indent="0" algn="r">
               <a:buNone/>
             </a:pPr>
             <a:r>
@@ -1319,7 +1093,7 @@
           </a:prstGeom>
           <a:extLst>
             <a:ext uri="{C572A759-6A51-4108-AA02-DFA0A04FC94B}">
-              <ma14:wrappingTextBoxFlag xmlns:ma14="http://schemas.microsoft.com/office/mac/drawingml/2011/main" val="0"/>
+              <ma14:wrappingTextBoxFlag xmlns:ma14="http://schemas.microsoft.com/office/mac/drawingml/2011/main" xmlns="" val="0"/>
             </a:ext>
           </a:extLst>
         </p:spPr>
@@ -1337,8 +1111,8 @@
           <a:p>
             <a:pPr algn="l"/>
             <a:fld id="{F7021451-1387-4CA6-816F-3879F97B5CBC}" type="slidenum">
-              <a:rPr b="0" lang="en-US"/>
-              <a:t>1002</a:t>
+              <a:rPr lang="en-US" b="0"/>
+              <a:t>‹#›</a:t>
             </a:fld>
             <a:endParaRPr lang="en-US"/>
           </a:p>
@@ -1355,6 +1129,11 @@
 <file path=ppt/slideMasters/slideMaster1.xml><?xml version="1.0" encoding="utf-8"?>
 <p:sldMaster xmlns:a="http://schemas.openxmlformats.org/drawingml/2006/main" xmlns:r="http://schemas.openxmlformats.org/officeDocument/2006/relationships" xmlns:p="http://schemas.openxmlformats.org/presentationml/2006/main">
   <p:cSld>
+    <p:bg>
+      <p:bgRef idx="1001">
+        <a:schemeClr val="bg1"/>
+      </p:bgRef>
+    </p:bg>
     <p:spTree>
       <p:nvGrpSpPr>
         <p:cNvPr id="1" name=""/>
@@ -1389,7 +1168,7 @@
           </a:prstGeom>
           <a:extLst>
             <a:ext uri="{C572A759-6A51-4108-AA02-DFA0A04FC94B}">
-              <ma14:wrappingTextBoxFlag xmlns:ma14="http://schemas.microsoft.com/office/mac/drawingml/2011/main" val="0"/>
+              <ma14:wrappingTextBoxFlag xmlns:ma14="http://schemas.microsoft.com/office/mac/drawingml/2011/main" xmlns="" val="0"/>
             </a:ext>
           </a:extLst>
         </p:spPr>
@@ -1407,8 +1186,8 @@
           <a:p>
             <a:pPr algn="l"/>
             <a:fld id="{F7021451-1387-4CA6-816F-3879F97B5CBC}" type="slidenum">
-              <a:rPr b="0" lang="en-US"/>
-              <a:t>null</a:t>
+              <a:rPr lang="en-US" b="0"/>
+              <a:t>‹#›</a:t>
             </a:fld>
             <a:endParaRPr lang="en-US"/>
           </a:p>
@@ -1683,6 +1462,7 @@
         <a:solidFill>
           <a:srgbClr val="071B31"/>
         </a:solidFill>
+        <a:effectLst/>
       </p:bgPr>
     </p:bg>
     <p:spTree>
@@ -1701,14 +1481,14 @@
       </p:grpSpPr>
       <p:pic>
         <p:nvPicPr>
-          <p:cNvPr id="2" name="Image 0" descr="D:\AI\Workspaces\CommerceOS-Submission-016\CommerceOS-cover.png">    </p:cNvPr>
+          <p:cNvPr id="2" name="Image 0" descr="D:\AI\Workspaces\CommerceOS-Submission-016\CommerceOS-cover.png"/>
           <p:cNvPicPr>
             <a:picLocks noChangeAspect="1"/>
           </p:cNvPicPr>
           <p:nvPr/>
         </p:nvPicPr>
         <p:blipFill>
-          <a:blip r:embed="rId1"/>
+          <a:blip r:embed="rId3"/>
           <a:stretch>
             <a:fillRect/>
           </a:stretch>
@@ -1769,7 +1549,7 @@
           <a:bodyPr wrap="square" lIns="0" tIns="0" rIns="0" bIns="0" rtlCol="0" anchor="ctr"/>
           <a:lstStyle/>
           <a:p>
-            <a:pPr indent="0" marL="0">
+            <a:pPr marL="0" indent="0">
               <a:buNone/>
             </a:pPr>
             <a:r>
@@ -1808,7 +1588,7 @@
           <a:bodyPr wrap="square" lIns="0" tIns="0" rIns="0" bIns="0" rtlCol="0" anchor="ctr"/>
           <a:lstStyle/>
           <a:p>
-            <a:pPr indent="0" marL="0">
+            <a:pPr marL="0" indent="0">
               <a:buNone/>
             </a:pPr>
             <a:r>
@@ -1852,7 +1632,7 @@
             <a:prstDash val="solid"/>
           </a:ln>
           <a:effectLst>
-            <a:outerShdw sx="100000" sy="100000" kx="0" ky="0" algn="bl" rotWithShape="0" blurRad="25400" dist="50800" dir="2700000">
+            <a:outerShdw blurRad="25400" dist="50800" dir="2700000" algn="bl" rotWithShape="0">
               <a:srgbClr val="7A90A2">
                 <a:alpha val="13000"/>
               </a:srgbClr>
@@ -1908,7 +1688,7 @@
           <a:bodyPr wrap="square" lIns="0" tIns="0" rIns="0" bIns="0" rtlCol="0" anchor="ctr"/>
           <a:lstStyle/>
           <a:p>
-            <a:pPr indent="0" marL="0">
+            <a:pPr marL="0" indent="0">
               <a:buNone/>
             </a:pPr>
             <a:r>
@@ -1947,7 +1727,7 @@
           <a:bodyPr wrap="square" lIns="508" tIns="508" rIns="508" bIns="508" rtlCol="0" anchor="t"/>
           <a:lstStyle/>
           <a:p>
-            <a:pPr indent="0" marL="0">
+            <a:pPr marL="0" indent="0">
               <a:buNone/>
             </a:pPr>
             <a:r>
@@ -1991,7 +1771,7 @@
             <a:prstDash val="solid"/>
           </a:ln>
           <a:effectLst>
-            <a:outerShdw sx="100000" sy="100000" kx="0" ky="0" algn="bl" rotWithShape="0" blurRad="25400" dist="50800" dir="2700000">
+            <a:outerShdw blurRad="25400" dist="50800" dir="2700000" algn="bl" rotWithShape="0">
               <a:srgbClr val="7A90A2">
                 <a:alpha val="13000"/>
               </a:srgbClr>
@@ -2047,7 +1827,7 @@
           <a:bodyPr wrap="square" lIns="0" tIns="0" rIns="0" bIns="0" rtlCol="0" anchor="ctr"/>
           <a:lstStyle/>
           <a:p>
-            <a:pPr indent="0" marL="0">
+            <a:pPr marL="0" indent="0">
               <a:buNone/>
             </a:pPr>
             <a:r>
@@ -2086,7 +1866,7 @@
           <a:bodyPr wrap="square" lIns="508" tIns="508" rIns="508" bIns="508" rtlCol="0" anchor="t"/>
           <a:lstStyle/>
           <a:p>
-            <a:pPr indent="0" marL="0">
+            <a:pPr marL="0" indent="0">
               <a:buNone/>
             </a:pPr>
             <a:r>
@@ -2130,7 +1910,7 @@
             <a:prstDash val="solid"/>
           </a:ln>
           <a:effectLst>
-            <a:outerShdw sx="100000" sy="100000" kx="0" ky="0" algn="bl" rotWithShape="0" blurRad="25400" dist="50800" dir="2700000">
+            <a:outerShdw blurRad="25400" dist="50800" dir="2700000" algn="bl" rotWithShape="0">
               <a:srgbClr val="7A90A2">
                 <a:alpha val="13000"/>
               </a:srgbClr>
@@ -2186,7 +1966,7 @@
           <a:bodyPr wrap="square" lIns="0" tIns="0" rIns="0" bIns="0" rtlCol="0" anchor="ctr"/>
           <a:lstStyle/>
           <a:p>
-            <a:pPr indent="0" marL="0">
+            <a:pPr marL="0" indent="0">
               <a:buNone/>
             </a:pPr>
             <a:r>
@@ -2225,7 +2005,7 @@
           <a:bodyPr wrap="square" lIns="508" tIns="508" rIns="508" bIns="508" rtlCol="0" anchor="t"/>
           <a:lstStyle/>
           <a:p>
-            <a:pPr indent="0" marL="0">
+            <a:pPr marL="0" indent="0">
               <a:buNone/>
             </a:pPr>
             <a:r>
@@ -2264,7 +2044,7 @@
           <a:bodyPr wrap="square" lIns="0" tIns="0" rIns="0" bIns="0" rtlCol="0" anchor="ctr"/>
           <a:lstStyle/>
           <a:p>
-            <a:pPr algn="ctr" indent="0" marL="0">
+            <a:pPr marL="0" indent="0" algn="ctr">
               <a:buNone/>
             </a:pPr>
             <a:r>
@@ -2302,7 +2082,7 @@
           </a:prstGeom>
           <a:extLst>
             <a:ext uri="{C572A759-6A51-4108-AA02-DFA0A04FC94B}">
-              <ma14:wrappingTextBoxFlag xmlns:ma14="http://schemas.microsoft.com/office/mac/drawingml/2011/main" val="0"/>
+              <ma14:wrappingTextBoxFlag xmlns:ma14="http://schemas.microsoft.com/office/mac/drawingml/2011/main" xmlns="" val="0"/>
             </a:ext>
           </a:extLst>
         </p:spPr>
@@ -2320,7 +2100,7 @@
           <a:p>
             <a:pPr algn="l"/>
             <a:fld id="{F7021451-1387-4CA6-816F-3879F97B5CBC}" type="slidenum">
-              <a:rPr b="0" lang="en-US"/>
+              <a:rPr lang="en-US" b="0"/>
               <a:t>2</a:t>
             </a:fld>
             <a:endParaRPr lang="en-US"/>
@@ -2373,7 +2153,7 @@
           <a:bodyPr wrap="square" lIns="0" tIns="0" rIns="0" bIns="0" rtlCol="0" anchor="ctr"/>
           <a:lstStyle/>
           <a:p>
-            <a:pPr indent="0" marL="0">
+            <a:pPr marL="0" indent="0">
               <a:buNone/>
             </a:pPr>
             <a:r>
@@ -2412,7 +2192,7 @@
           <a:bodyPr wrap="square" lIns="0" tIns="0" rIns="0" bIns="0" rtlCol="0" anchor="ctr"/>
           <a:lstStyle/>
           <a:p>
-            <a:pPr indent="0" marL="0">
+            <a:pPr marL="0" indent="0">
               <a:buNone/>
             </a:pPr>
             <a:r>
@@ -2432,14 +2212,14 @@
       </p:sp>
       <p:pic>
         <p:nvPicPr>
-          <p:cNvPr id="4" name="Image 0" descr="D:\AI\Workspaces\CommerceOS-Submission-016\promiseguard-at-risk-results.png">    </p:cNvPr>
+          <p:cNvPr id="4" name="Image 0" descr="D:\AI\Workspaces\CommerceOS-Submission-016\promiseguard-at-risk-results.png"/>
           <p:cNvPicPr>
             <a:picLocks noChangeAspect="1"/>
           </p:cNvPicPr>
           <p:nvPr/>
         </p:nvPicPr>
         <p:blipFill>
-          <a:blip r:embed="rId1"/>
+          <a:blip r:embed="rId3"/>
           <a:stretch>
             <a:fillRect/>
           </a:stretch>
@@ -2480,7 +2260,7 @@
             <a:prstDash val="solid"/>
           </a:ln>
           <a:effectLst>
-            <a:outerShdw sx="100000" sy="100000" kx="0" ky="0" algn="bl" rotWithShape="0" blurRad="25400" dist="50800" dir="2700000">
+            <a:outerShdw blurRad="25400" dist="50800" dir="2700000" algn="bl" rotWithShape="0">
               <a:srgbClr val="7A90A2">
                 <a:alpha val="13000"/>
               </a:srgbClr>
@@ -2536,7 +2316,7 @@
           <a:bodyPr wrap="square" lIns="0" tIns="0" rIns="0" bIns="0" rtlCol="0" anchor="ctr"/>
           <a:lstStyle/>
           <a:p>
-            <a:pPr indent="0" marL="0">
+            <a:pPr marL="0" indent="0">
               <a:buNone/>
             </a:pPr>
             <a:r>
@@ -2575,7 +2355,7 @@
           <a:bodyPr wrap="square" lIns="508" tIns="508" rIns="508" bIns="508" rtlCol="0" anchor="t"/>
           <a:lstStyle/>
           <a:p>
-            <a:pPr indent="0" marL="0">
+            <a:pPr marL="0" indent="0">
               <a:buNone/>
             </a:pPr>
             <a:r>
@@ -2619,7 +2399,7 @@
             <a:prstDash val="solid"/>
           </a:ln>
           <a:effectLst>
-            <a:outerShdw sx="100000" sy="100000" kx="0" ky="0" algn="bl" rotWithShape="0" blurRad="25400" dist="50800" dir="2700000">
+            <a:outerShdw blurRad="25400" dist="50800" dir="2700000" algn="bl" rotWithShape="0">
               <a:srgbClr val="7A90A2">
                 <a:alpha val="13000"/>
               </a:srgbClr>
@@ -2675,7 +2455,7 @@
           <a:bodyPr wrap="square" lIns="0" tIns="0" rIns="0" bIns="0" rtlCol="0" anchor="ctr"/>
           <a:lstStyle/>
           <a:p>
-            <a:pPr indent="0" marL="0">
+            <a:pPr marL="0" indent="0">
               <a:buNone/>
             </a:pPr>
             <a:r>
@@ -2714,7 +2494,7 @@
           <a:bodyPr wrap="square" lIns="508" tIns="508" rIns="508" bIns="508" rtlCol="0" anchor="t"/>
           <a:lstStyle/>
           <a:p>
-            <a:pPr indent="0" marL="0">
+            <a:pPr marL="0" indent="0">
               <a:buNone/>
             </a:pPr>
             <a:r>
@@ -2758,7 +2538,7 @@
             <a:prstDash val="solid"/>
           </a:ln>
           <a:effectLst>
-            <a:outerShdw sx="100000" sy="100000" kx="0" ky="0" algn="bl" rotWithShape="0" blurRad="25400" dist="50800" dir="2700000">
+            <a:outerShdw blurRad="25400" dist="50800" dir="2700000" algn="bl" rotWithShape="0">
               <a:srgbClr val="7A90A2">
                 <a:alpha val="13000"/>
               </a:srgbClr>
@@ -2814,7 +2594,7 @@
           <a:bodyPr wrap="square" lIns="0" tIns="0" rIns="0" bIns="0" rtlCol="0" anchor="ctr"/>
           <a:lstStyle/>
           <a:p>
-            <a:pPr indent="0" marL="0">
+            <a:pPr marL="0" indent="0">
               <a:buNone/>
             </a:pPr>
             <a:r>
@@ -2853,7 +2633,7 @@
           <a:bodyPr wrap="square" lIns="508" tIns="508" rIns="508" bIns="508" rtlCol="0" anchor="t"/>
           <a:lstStyle/>
           <a:p>
-            <a:pPr indent="0" marL="0">
+            <a:pPr marL="0" indent="0">
               <a:buNone/>
             </a:pPr>
             <a:r>
@@ -2892,7 +2672,7 @@
           <a:bodyPr wrap="square" lIns="0" tIns="0" rIns="0" bIns="0" rtlCol="0" anchor="ctr"/>
           <a:lstStyle/>
           <a:p>
-            <a:pPr indent="0" marL="0">
+            <a:pPr marL="0" indent="0">
               <a:buNone/>
             </a:pPr>
             <a:r>
@@ -2930,7 +2710,7 @@
           </a:prstGeom>
           <a:extLst>
             <a:ext uri="{C572A759-6A51-4108-AA02-DFA0A04FC94B}">
-              <ma14:wrappingTextBoxFlag xmlns:ma14="http://schemas.microsoft.com/office/mac/drawingml/2011/main" val="0"/>
+              <ma14:wrappingTextBoxFlag xmlns:ma14="http://schemas.microsoft.com/office/mac/drawingml/2011/main" xmlns="" val="0"/>
             </a:ext>
           </a:extLst>
         </p:spPr>
@@ -2948,7 +2728,7 @@
           <a:p>
             <a:pPr algn="l"/>
             <a:fld id="{F7021451-1387-4CA6-816F-3879F97B5CBC}" type="slidenum">
-              <a:rPr b="0" lang="en-US"/>
+              <a:rPr lang="en-US" b="0"/>
               <a:t>3</a:t>
             </a:fld>
             <a:endParaRPr lang="en-US"/>
@@ -3001,7 +2781,7 @@
           <a:bodyPr wrap="square" lIns="0" tIns="0" rIns="0" bIns="0" rtlCol="0" anchor="ctr"/>
           <a:lstStyle/>
           <a:p>
-            <a:pPr indent="0" marL="0">
+            <a:pPr marL="0" indent="0">
               <a:buNone/>
             </a:pPr>
             <a:r>
@@ -3040,7 +2820,7 @@
           <a:bodyPr wrap="square" lIns="0" tIns="0" rIns="0" bIns="0" rtlCol="0" anchor="ctr"/>
           <a:lstStyle/>
           <a:p>
-            <a:pPr indent="0" marL="0">
+            <a:pPr marL="0" indent="0">
               <a:buNone/>
             </a:pPr>
             <a:r>
@@ -3060,14 +2840,14 @@
       </p:sp>
       <p:pic>
         <p:nvPicPr>
-          <p:cNvPr id="4" name="Image 0" descr="D:\AI\Workspaces\CommerceOS-Submission-016\marginleak-confirmed-results.png">    </p:cNvPr>
+          <p:cNvPr id="4" name="Image 0" descr="D:\AI\Workspaces\CommerceOS-Submission-016\marginleak-confirmed-results.png"/>
           <p:cNvPicPr>
             <a:picLocks noChangeAspect="1"/>
           </p:cNvPicPr>
           <p:nvPr/>
         </p:nvPicPr>
         <p:blipFill>
-          <a:blip r:embed="rId1"/>
+          <a:blip r:embed="rId3"/>
           <a:stretch>
             <a:fillRect/>
           </a:stretch>
@@ -3103,7 +2883,7 @@
           <a:bodyPr wrap="square" lIns="0" tIns="0" rIns="0" bIns="0" rtlCol="0" anchor="ctr"/>
           <a:lstStyle/>
           <a:p>
-            <a:pPr indent="0" marL="0">
+            <a:pPr marL="0" indent="0">
               <a:buNone/>
             </a:pPr>
             <a:r>
@@ -3142,7 +2922,7 @@
           <a:bodyPr wrap="square" lIns="0" tIns="0" rIns="0" bIns="0" rtlCol="0" anchor="ctr"/>
           <a:lstStyle/>
           <a:p>
-            <a:pPr indent="0" marL="0">
+            <a:pPr marL="0" indent="0">
               <a:buNone/>
             </a:pPr>
             <a:r>
@@ -3181,7 +2961,7 @@
           <a:bodyPr wrap="square" lIns="0" tIns="0" rIns="0" bIns="0" rtlCol="0" anchor="ctr"/>
           <a:lstStyle/>
           <a:p>
-            <a:pPr indent="0" marL="0">
+            <a:pPr marL="0" indent="0">
               <a:buNone/>
             </a:pPr>
             <a:r>
@@ -3220,7 +3000,7 @@
           <a:bodyPr wrap="square" lIns="0" tIns="0" rIns="0" bIns="0" rtlCol="0" anchor="ctr"/>
           <a:lstStyle/>
           <a:p>
-            <a:pPr indent="0" marL="0">
+            <a:pPr marL="0" indent="0">
               <a:buNone/>
             </a:pPr>
             <a:r>
@@ -3259,7 +3039,7 @@
           <a:bodyPr wrap="square" lIns="0" tIns="0" rIns="0" bIns="0" rtlCol="0" anchor="ctr"/>
           <a:lstStyle/>
           <a:p>
-            <a:pPr indent="0" marL="0">
+            <a:pPr marL="0" indent="0">
               <a:buNone/>
             </a:pPr>
             <a:r>
@@ -3298,7 +3078,7 @@
           <a:bodyPr wrap="square" lIns="0" tIns="0" rIns="0" bIns="0" rtlCol="0" anchor="ctr"/>
           <a:lstStyle/>
           <a:p>
-            <a:pPr indent="0" marL="0">
+            <a:pPr marL="0" indent="0">
               <a:buNone/>
             </a:pPr>
             <a:r>
@@ -3337,7 +3117,7 @@
           <a:bodyPr wrap="square" lIns="0" tIns="0" rIns="0" bIns="0" rtlCol="0" anchor="ctr"/>
           <a:lstStyle/>
           <a:p>
-            <a:pPr indent="0" marL="0">
+            <a:pPr marL="0" indent="0">
               <a:buNone/>
             </a:pPr>
             <a:r>
@@ -3375,7 +3155,7 @@
           </a:prstGeom>
           <a:extLst>
             <a:ext uri="{C572A759-6A51-4108-AA02-DFA0A04FC94B}">
-              <ma14:wrappingTextBoxFlag xmlns:ma14="http://schemas.microsoft.com/office/mac/drawingml/2011/main" val="0"/>
+              <ma14:wrappingTextBoxFlag xmlns:ma14="http://schemas.microsoft.com/office/mac/drawingml/2011/main" xmlns="" val="0"/>
             </a:ext>
           </a:extLst>
         </p:spPr>
@@ -3393,7 +3173,7 @@
           <a:p>
             <a:pPr algn="l"/>
             <a:fld id="{F7021451-1387-4CA6-816F-3879F97B5CBC}" type="slidenum">
-              <a:rPr b="0" lang="en-US"/>
+              <a:rPr lang="en-US" b="0"/>
               <a:t>4</a:t>
             </a:fld>
             <a:endParaRPr lang="en-US"/>
@@ -3446,7 +3226,7 @@
           <a:bodyPr wrap="square" lIns="0" tIns="0" rIns="0" bIns="0" rtlCol="0" anchor="ctr"/>
           <a:lstStyle/>
           <a:p>
-            <a:pPr indent="0" marL="0">
+            <a:pPr marL="0" indent="0">
               <a:buNone/>
             </a:pPr>
             <a:r>
@@ -3485,7 +3265,7 @@
           <a:bodyPr wrap="square" lIns="0" tIns="0" rIns="0" bIns="0" rtlCol="0" anchor="ctr"/>
           <a:lstStyle/>
           <a:p>
-            <a:pPr indent="0" marL="0">
+            <a:pPr marL="0" indent="0">
               <a:buNone/>
             </a:pPr>
             <a:r>
@@ -3551,7 +3331,7 @@
           <a:bodyPr wrap="square" lIns="254" tIns="254" rIns="254" bIns="254" rtlCol="0" anchor="ctr"/>
           <a:lstStyle/>
           <a:p>
-            <a:pPr algn="ctr" indent="0" marL="0">
+            <a:pPr marL="0" indent="0" algn="ctr">
               <a:buNone/>
             </a:pPr>
             <a:r>
@@ -3642,7 +3422,7 @@
           <a:bodyPr wrap="square" lIns="254" tIns="254" rIns="254" bIns="254" rtlCol="0" anchor="ctr"/>
           <a:lstStyle/>
           <a:p>
-            <a:pPr algn="ctr" indent="0" marL="0">
+            <a:pPr marL="0" indent="0" algn="ctr">
               <a:buNone/>
             </a:pPr>
             <a:r>
@@ -3733,7 +3513,7 @@
           <a:bodyPr wrap="square" lIns="254" tIns="254" rIns="254" bIns="254" rtlCol="0" anchor="ctr"/>
           <a:lstStyle/>
           <a:p>
-            <a:pPr algn="ctr" indent="0" marL="0">
+            <a:pPr marL="0" indent="0" algn="ctr">
               <a:buNone/>
             </a:pPr>
             <a:r>
@@ -3824,7 +3604,7 @@
           <a:bodyPr wrap="square" lIns="254" tIns="254" rIns="254" bIns="254" rtlCol="0" anchor="ctr"/>
           <a:lstStyle/>
           <a:p>
-            <a:pPr algn="ctr" indent="0" marL="0">
+            <a:pPr marL="0" indent="0" algn="ctr">
               <a:buNone/>
             </a:pPr>
             <a:r>
@@ -3915,7 +3695,7 @@
           <a:bodyPr wrap="square" lIns="254" tIns="254" rIns="254" bIns="254" rtlCol="0" anchor="ctr"/>
           <a:lstStyle/>
           <a:p>
-            <a:pPr algn="ctr" indent="0" marL="0">
+            <a:pPr marL="0" indent="0" algn="ctr">
               <a:buNone/>
             </a:pPr>
             <a:r>
@@ -3959,7 +3739,7 @@
             <a:prstDash val="solid"/>
           </a:ln>
           <a:effectLst>
-            <a:outerShdw sx="100000" sy="100000" kx="0" ky="0" algn="bl" rotWithShape="0" blurRad="25400" dist="50800" dir="2700000">
+            <a:outerShdw blurRad="25400" dist="50800" dir="2700000" algn="bl" rotWithShape="0">
               <a:srgbClr val="7A90A2">
                 <a:alpha val="13000"/>
               </a:srgbClr>
@@ -4015,7 +3795,7 @@
           <a:bodyPr wrap="square" lIns="0" tIns="0" rIns="0" bIns="0" rtlCol="0" anchor="ctr"/>
           <a:lstStyle/>
           <a:p>
-            <a:pPr indent="0" marL="0">
+            <a:pPr marL="0" indent="0">
               <a:buNone/>
             </a:pPr>
             <a:r>
@@ -4054,7 +3834,7 @@
           <a:bodyPr wrap="square" lIns="508" tIns="508" rIns="508" bIns="508" rtlCol="0" anchor="t"/>
           <a:lstStyle/>
           <a:p>
-            <a:pPr indent="0" marL="0">
+            <a:pPr marL="0" indent="0">
               <a:buNone/>
             </a:pPr>
             <a:r>
@@ -4098,7 +3878,7 @@
             <a:prstDash val="solid"/>
           </a:ln>
           <a:effectLst>
-            <a:outerShdw sx="100000" sy="100000" kx="0" ky="0" algn="bl" rotWithShape="0" blurRad="25400" dist="50800" dir="2700000">
+            <a:outerShdw blurRad="25400" dist="50800" dir="2700000" algn="bl" rotWithShape="0">
               <a:srgbClr val="7A90A2">
                 <a:alpha val="13000"/>
               </a:srgbClr>
@@ -4154,7 +3934,7 @@
           <a:bodyPr wrap="square" lIns="0" tIns="0" rIns="0" bIns="0" rtlCol="0" anchor="ctr"/>
           <a:lstStyle/>
           <a:p>
-            <a:pPr indent="0" marL="0">
+            <a:pPr marL="0" indent="0">
               <a:buNone/>
             </a:pPr>
             <a:r>
@@ -4193,7 +3973,7 @@
           <a:bodyPr wrap="square" lIns="508" tIns="508" rIns="508" bIns="508" rtlCol="0" anchor="t"/>
           <a:lstStyle/>
           <a:p>
-            <a:pPr indent="0" marL="0">
+            <a:pPr marL="0" indent="0">
               <a:buNone/>
             </a:pPr>
             <a:r>
@@ -4237,7 +4017,7 @@
             <a:prstDash val="solid"/>
           </a:ln>
           <a:effectLst>
-            <a:outerShdw sx="100000" sy="100000" kx="0" ky="0" algn="bl" rotWithShape="0" blurRad="25400" dist="50800" dir="2700000">
+            <a:outerShdw blurRad="25400" dist="50800" dir="2700000" algn="bl" rotWithShape="0">
               <a:srgbClr val="7A90A2">
                 <a:alpha val="13000"/>
               </a:srgbClr>
@@ -4293,7 +4073,7 @@
           <a:bodyPr wrap="square" lIns="0" tIns="0" rIns="0" bIns="0" rtlCol="0" anchor="ctr"/>
           <a:lstStyle/>
           <a:p>
-            <a:pPr indent="0" marL="0">
+            <a:pPr marL="0" indent="0">
               <a:buNone/>
             </a:pPr>
             <a:r>
@@ -4332,7 +4112,7 @@
           <a:bodyPr wrap="square" lIns="508" tIns="508" rIns="508" bIns="508" rtlCol="0" anchor="t"/>
           <a:lstStyle/>
           <a:p>
-            <a:pPr indent="0" marL="0">
+            <a:pPr marL="0" indent="0">
               <a:buNone/>
             </a:pPr>
             <a:r>
@@ -4352,7 +4132,7 @@
       </p:sp>
       <p:sp>
         <p:nvSpPr>
-          <p:cNvPr id="25" name="Slide Number Placeholder 0"/>
+          <p:cNvPr id="30" name="Slide Number Placeholder 0"/>
           <p:cNvSpPr>
             <a:spLocks noGrp="1"/>
           </p:cNvSpPr>
@@ -4370,7 +4150,7 @@
           </a:prstGeom>
           <a:extLst>
             <a:ext uri="{C572A759-6A51-4108-AA02-DFA0A04FC94B}">
-              <ma14:wrappingTextBoxFlag xmlns:ma14="http://schemas.microsoft.com/office/mac/drawingml/2011/main" val="0"/>
+              <ma14:wrappingTextBoxFlag xmlns:ma14="http://schemas.microsoft.com/office/mac/drawingml/2011/main" xmlns="" val="0"/>
             </a:ext>
           </a:extLst>
         </p:spPr>
@@ -4388,7 +4168,7 @@
           <a:p>
             <a:pPr algn="l"/>
             <a:fld id="{F7021451-1387-4CA6-816F-3879F97B5CBC}" type="slidenum">
-              <a:rPr b="0" lang="en-US"/>
+              <a:rPr lang="en-US" b="0"/>
               <a:t>5</a:t>
             </a:fld>
             <a:endParaRPr lang="en-US"/>
@@ -4441,7 +4221,7 @@
           <a:bodyPr wrap="square" lIns="0" tIns="0" rIns="0" bIns="0" rtlCol="0" anchor="ctr"/>
           <a:lstStyle/>
           <a:p>
-            <a:pPr indent="0" marL="0">
+            <a:pPr marL="0" indent="0">
               <a:buNone/>
             </a:pPr>
             <a:r>
@@ -4480,7 +4260,7 @@
           <a:bodyPr wrap="square" lIns="0" tIns="0" rIns="0" bIns="0" rtlCol="0" anchor="ctr"/>
           <a:lstStyle/>
           <a:p>
-            <a:pPr indent="0" marL="0">
+            <a:pPr marL="0" indent="0">
               <a:buNone/>
             </a:pPr>
             <a:r>
@@ -4524,7 +4304,7 @@
             <a:prstDash val="solid"/>
           </a:ln>
           <a:effectLst>
-            <a:outerShdw sx="100000" sy="100000" kx="0" ky="0" algn="bl" rotWithShape="0" blurRad="25400" dist="50800" dir="2700000">
+            <a:outerShdw blurRad="25400" dist="50800" dir="2700000" algn="bl" rotWithShape="0">
               <a:srgbClr val="7A90A2">
                 <a:alpha val="13000"/>
               </a:srgbClr>
@@ -4580,7 +4360,7 @@
           <a:bodyPr wrap="square" lIns="0" tIns="0" rIns="0" bIns="0" rtlCol="0" anchor="ctr"/>
           <a:lstStyle/>
           <a:p>
-            <a:pPr indent="0" marL="0">
+            <a:pPr marL="0" indent="0">
               <a:buNone/>
             </a:pPr>
             <a:r>
@@ -4619,7 +4399,7 @@
           <a:bodyPr wrap="square" lIns="508" tIns="508" rIns="508" bIns="508" rtlCol="0" anchor="t"/>
           <a:lstStyle/>
           <a:p>
-            <a:pPr indent="0" marL="0">
+            <a:pPr marL="0" indent="0">
               <a:buNone/>
             </a:pPr>
             <a:r>
@@ -4663,7 +4443,7 @@
             <a:prstDash val="solid"/>
           </a:ln>
           <a:effectLst>
-            <a:outerShdw sx="100000" sy="100000" kx="0" ky="0" algn="bl" rotWithShape="0" blurRad="25400" dist="50800" dir="2700000">
+            <a:outerShdw blurRad="25400" dist="50800" dir="2700000" algn="bl" rotWithShape="0">
               <a:srgbClr val="7A90A2">
                 <a:alpha val="13000"/>
               </a:srgbClr>
@@ -4719,7 +4499,7 @@
           <a:bodyPr wrap="square" lIns="0" tIns="0" rIns="0" bIns="0" rtlCol="0" anchor="ctr"/>
           <a:lstStyle/>
           <a:p>
-            <a:pPr indent="0" marL="0">
+            <a:pPr marL="0" indent="0">
               <a:buNone/>
             </a:pPr>
             <a:r>
@@ -4758,7 +4538,7 @@
           <a:bodyPr wrap="square" lIns="508" tIns="508" rIns="508" bIns="508" rtlCol="0" anchor="t"/>
           <a:lstStyle/>
           <a:p>
-            <a:pPr indent="0" marL="0">
+            <a:pPr marL="0" indent="0">
               <a:buNone/>
             </a:pPr>
             <a:r>
@@ -4802,7 +4582,7 @@
             <a:prstDash val="solid"/>
           </a:ln>
           <a:effectLst>
-            <a:outerShdw sx="100000" sy="100000" kx="0" ky="0" algn="bl" rotWithShape="0" blurRad="25400" dist="50800" dir="2700000">
+            <a:outerShdw blurRad="25400" dist="50800" dir="2700000" algn="bl" rotWithShape="0">
               <a:srgbClr val="7A90A2">
                 <a:alpha val="13000"/>
               </a:srgbClr>
@@ -4858,7 +4638,7 @@
           <a:bodyPr wrap="square" lIns="0" tIns="0" rIns="0" bIns="0" rtlCol="0" anchor="ctr"/>
           <a:lstStyle/>
           <a:p>
-            <a:pPr indent="0" marL="0">
+            <a:pPr marL="0" indent="0">
               <a:buNone/>
             </a:pPr>
             <a:r>
@@ -4897,7 +4677,7 @@
           <a:bodyPr wrap="square" lIns="508" tIns="508" rIns="508" bIns="508" rtlCol="0" anchor="t"/>
           <a:lstStyle/>
           <a:p>
-            <a:pPr indent="0" marL="0">
+            <a:pPr marL="0" indent="0">
               <a:buNone/>
             </a:pPr>
             <a:r>
@@ -4941,7 +4721,7 @@
             <a:prstDash val="solid"/>
           </a:ln>
           <a:effectLst>
-            <a:outerShdw sx="100000" sy="100000" kx="0" ky="0" algn="bl" rotWithShape="0" blurRad="25400" dist="50800" dir="2700000">
+            <a:outerShdw blurRad="25400" dist="50800" dir="2700000" algn="bl" rotWithShape="0">
               <a:srgbClr val="7A90A2">
                 <a:alpha val="13000"/>
               </a:srgbClr>
@@ -4997,7 +4777,7 @@
           <a:bodyPr wrap="square" lIns="0" tIns="0" rIns="0" bIns="0" rtlCol="0" anchor="ctr"/>
           <a:lstStyle/>
           <a:p>
-            <a:pPr indent="0" marL="0">
+            <a:pPr marL="0" indent="0">
               <a:buNone/>
             </a:pPr>
             <a:r>
@@ -5036,7 +4816,7 @@
           <a:bodyPr wrap="square" lIns="508" tIns="508" rIns="508" bIns="508" rtlCol="0" anchor="t"/>
           <a:lstStyle/>
           <a:p>
-            <a:pPr indent="0" marL="0">
+            <a:pPr marL="0" indent="0">
               <a:buNone/>
             </a:pPr>
             <a:r>
@@ -5080,7 +4860,7 @@
             <a:prstDash val="solid"/>
           </a:ln>
           <a:effectLst>
-            <a:outerShdw sx="100000" sy="100000" kx="0" ky="0" algn="bl" rotWithShape="0" blurRad="25400" dist="50800" dir="2700000">
+            <a:outerShdw blurRad="25400" dist="50800" dir="2700000" algn="bl" rotWithShape="0">
               <a:srgbClr val="7A90A2">
                 <a:alpha val="13000"/>
               </a:srgbClr>
@@ -5136,7 +4916,7 @@
           <a:bodyPr wrap="square" lIns="0" tIns="0" rIns="0" bIns="0" rtlCol="0" anchor="ctr"/>
           <a:lstStyle/>
           <a:p>
-            <a:pPr indent="0" marL="0">
+            <a:pPr marL="0" indent="0">
               <a:buNone/>
             </a:pPr>
             <a:r>
@@ -5175,7 +4955,7 @@
           <a:bodyPr wrap="square" lIns="508" tIns="508" rIns="508" bIns="508" rtlCol="0" anchor="t"/>
           <a:lstStyle/>
           <a:p>
-            <a:pPr indent="0" marL="0">
+            <a:pPr marL="0" indent="0">
               <a:buNone/>
             </a:pPr>
             <a:r>
@@ -5219,7 +4999,7 @@
             <a:prstDash val="solid"/>
           </a:ln>
           <a:effectLst>
-            <a:outerShdw sx="100000" sy="100000" kx="0" ky="0" algn="bl" rotWithShape="0" blurRad="25400" dist="50800" dir="2700000">
+            <a:outerShdw blurRad="25400" dist="50800" dir="2700000" algn="bl" rotWithShape="0">
               <a:srgbClr val="7A90A2">
                 <a:alpha val="13000"/>
               </a:srgbClr>
@@ -5275,7 +5055,7 @@
           <a:bodyPr wrap="square" lIns="0" tIns="0" rIns="0" bIns="0" rtlCol="0" anchor="ctr"/>
           <a:lstStyle/>
           <a:p>
-            <a:pPr indent="0" marL="0">
+            <a:pPr marL="0" indent="0">
               <a:buNone/>
             </a:pPr>
             <a:r>
@@ -5314,7 +5094,7 @@
           <a:bodyPr wrap="square" lIns="508" tIns="508" rIns="508" bIns="508" rtlCol="0" anchor="t"/>
           <a:lstStyle/>
           <a:p>
-            <a:pPr indent="0" marL="0">
+            <a:pPr marL="0" indent="0">
               <a:buNone/>
             </a:pPr>
             <a:r>
@@ -5353,7 +5133,7 @@
           <a:bodyPr wrap="square" lIns="0" tIns="0" rIns="0" bIns="0" rtlCol="0" anchor="ctr"/>
           <a:lstStyle/>
           <a:p>
-            <a:pPr algn="ctr" indent="0" marL="0">
+            <a:pPr marL="0" indent="0" algn="ctr">
               <a:buNone/>
             </a:pPr>
             <a:r>
@@ -5373,7 +5153,7 @@
       </p:sp>
       <p:sp>
         <p:nvSpPr>
-          <p:cNvPr id="25" name="Slide Number Placeholder 0"/>
+          <p:cNvPr id="29" name="Slide Number Placeholder 0"/>
           <p:cNvSpPr>
             <a:spLocks noGrp="1"/>
           </p:cNvSpPr>
@@ -5391,7 +5171,7 @@
           </a:prstGeom>
           <a:extLst>
             <a:ext uri="{C572A759-6A51-4108-AA02-DFA0A04FC94B}">
-              <ma14:wrappingTextBoxFlag xmlns:ma14="http://schemas.microsoft.com/office/mac/drawingml/2011/main" val="0"/>
+              <ma14:wrappingTextBoxFlag xmlns:ma14="http://schemas.microsoft.com/office/mac/drawingml/2011/main" xmlns="" val="0"/>
             </a:ext>
           </a:extLst>
         </p:spPr>
@@ -5409,7 +5189,7 @@
           <a:p>
             <a:pPr algn="l"/>
             <a:fld id="{F7021451-1387-4CA6-816F-3879F97B5CBC}" type="slidenum">
-              <a:rPr b="0" lang="en-US"/>
+              <a:rPr lang="en-US" b="0"/>
               <a:t>6</a:t>
             </a:fld>
             <a:endParaRPr lang="en-US"/>
@@ -5462,7 +5242,7 @@
           <a:bodyPr wrap="square" lIns="0" tIns="0" rIns="0" bIns="0" rtlCol="0" anchor="ctr"/>
           <a:lstStyle/>
           <a:p>
-            <a:pPr indent="0" marL="0">
+            <a:pPr marL="0" indent="0">
               <a:buNone/>
             </a:pPr>
             <a:r>
@@ -5501,7 +5281,7 @@
           <a:bodyPr wrap="square" lIns="0" tIns="0" rIns="0" bIns="0" rtlCol="0" anchor="ctr"/>
           <a:lstStyle/>
           <a:p>
-            <a:pPr indent="0" marL="0">
+            <a:pPr marL="0" indent="0">
               <a:buNone/>
             </a:pPr>
             <a:r>
@@ -5567,7 +5347,7 @@
           <a:bodyPr wrap="square" lIns="0" tIns="0" rIns="0" bIns="0" rtlCol="0" anchor="ctr"/>
           <a:lstStyle/>
           <a:p>
-            <a:pPr algn="ctr" indent="0" marL="0">
+            <a:pPr marL="0" indent="0" algn="ctr">
               <a:buNone/>
             </a:pPr>
             <a:r>
@@ -5606,7 +5386,7 @@
           <a:bodyPr wrap="square" lIns="0" tIns="0" rIns="0" bIns="0" rtlCol="0" anchor="ctr"/>
           <a:lstStyle/>
           <a:p>
-            <a:pPr algn="ctr" indent="0" marL="0">
+            <a:pPr marL="0" indent="0" algn="ctr">
               <a:buNone/>
             </a:pPr>
             <a:r>
@@ -5672,7 +5452,7 @@
           <a:bodyPr wrap="square" lIns="0" tIns="0" rIns="0" bIns="0" rtlCol="0" anchor="ctr"/>
           <a:lstStyle/>
           <a:p>
-            <a:pPr algn="ctr" indent="0" marL="0">
+            <a:pPr marL="0" indent="0" algn="ctr">
               <a:buNone/>
             </a:pPr>
             <a:r>
@@ -5711,7 +5491,7 @@
           <a:bodyPr wrap="square" lIns="0" tIns="0" rIns="0" bIns="0" rtlCol="0" anchor="ctr"/>
           <a:lstStyle/>
           <a:p>
-            <a:pPr algn="ctr" indent="0" marL="0">
+            <a:pPr marL="0" indent="0" algn="ctr">
               <a:buNone/>
             </a:pPr>
             <a:r>
@@ -5777,7 +5557,7 @@
           <a:bodyPr wrap="square" lIns="0" tIns="0" rIns="0" bIns="0" rtlCol="0" anchor="ctr"/>
           <a:lstStyle/>
           <a:p>
-            <a:pPr algn="ctr" indent="0" marL="0">
+            <a:pPr marL="0" indent="0" algn="ctr">
               <a:buNone/>
             </a:pPr>
             <a:r>
@@ -5816,7 +5596,7 @@
           <a:bodyPr wrap="square" lIns="0" tIns="0" rIns="0" bIns="0" rtlCol="0" anchor="ctr"/>
           <a:lstStyle/>
           <a:p>
-            <a:pPr algn="ctr" indent="0" marL="0">
+            <a:pPr marL="0" indent="0" algn="ctr">
               <a:buNone/>
             </a:pPr>
             <a:r>
@@ -5882,7 +5662,7 @@
           <a:bodyPr wrap="square" lIns="0" tIns="0" rIns="0" bIns="0" rtlCol="0" anchor="ctr"/>
           <a:lstStyle/>
           <a:p>
-            <a:pPr algn="ctr" indent="0" marL="0">
+            <a:pPr marL="0" indent="0" algn="ctr">
               <a:buNone/>
             </a:pPr>
             <a:r>
@@ -5921,7 +5701,7 @@
           <a:bodyPr wrap="square" lIns="0" tIns="0" rIns="0" bIns="0" rtlCol="0" anchor="ctr"/>
           <a:lstStyle/>
           <a:p>
-            <a:pPr algn="ctr" indent="0" marL="0">
+            <a:pPr marL="0" indent="0" algn="ctr">
               <a:buNone/>
             </a:pPr>
             <a:r>
@@ -5965,7 +5745,7 @@
             <a:prstDash val="solid"/>
           </a:ln>
           <a:effectLst>
-            <a:outerShdw sx="100000" sy="100000" kx="0" ky="0" algn="bl" rotWithShape="0" blurRad="25400" dist="50800" dir="2700000">
+            <a:outerShdw blurRad="25400" dist="50800" dir="2700000" algn="bl" rotWithShape="0">
               <a:srgbClr val="7A90A2">
                 <a:alpha val="13000"/>
               </a:srgbClr>
@@ -6021,7 +5801,7 @@
           <a:bodyPr wrap="square" lIns="0" tIns="0" rIns="0" bIns="0" rtlCol="0" anchor="ctr"/>
           <a:lstStyle/>
           <a:p>
-            <a:pPr indent="0" marL="0">
+            <a:pPr marL="0" indent="0">
               <a:buNone/>
             </a:pPr>
             <a:r>
@@ -6060,7 +5840,7 @@
           <a:bodyPr wrap="square" lIns="508" tIns="508" rIns="508" bIns="508" rtlCol="0" anchor="t"/>
           <a:lstStyle/>
           <a:p>
-            <a:pPr indent="0" marL="0">
+            <a:pPr marL="0" indent="0">
               <a:buNone/>
             </a:pPr>
             <a:r>
@@ -6104,7 +5884,7 @@
             <a:prstDash val="solid"/>
           </a:ln>
           <a:effectLst>
-            <a:outerShdw sx="100000" sy="100000" kx="0" ky="0" algn="bl" rotWithShape="0" blurRad="25400" dist="50800" dir="2700000">
+            <a:outerShdw blurRad="25400" dist="50800" dir="2700000" algn="bl" rotWithShape="0">
               <a:srgbClr val="7A90A2">
                 <a:alpha val="13000"/>
               </a:srgbClr>
@@ -6160,7 +5940,7 @@
           <a:bodyPr wrap="square" lIns="0" tIns="0" rIns="0" bIns="0" rtlCol="0" anchor="ctr"/>
           <a:lstStyle/>
           <a:p>
-            <a:pPr indent="0" marL="0">
+            <a:pPr marL="0" indent="0">
               <a:buNone/>
             </a:pPr>
             <a:r>
@@ -6199,7 +5979,7 @@
           <a:bodyPr wrap="square" lIns="508" tIns="508" rIns="508" bIns="508" rtlCol="0" anchor="t"/>
           <a:lstStyle/>
           <a:p>
-            <a:pPr indent="0" marL="0">
+            <a:pPr marL="0" indent="0">
               <a:buNone/>
             </a:pPr>
             <a:r>
@@ -6243,7 +6023,7 @@
             <a:prstDash val="solid"/>
           </a:ln>
           <a:effectLst>
-            <a:outerShdw sx="100000" sy="100000" kx="0" ky="0" algn="bl" rotWithShape="0" blurRad="25400" dist="50800" dir="2700000">
+            <a:outerShdw blurRad="25400" dist="50800" dir="2700000" algn="bl" rotWithShape="0">
               <a:srgbClr val="7A90A2">
                 <a:alpha val="13000"/>
               </a:srgbClr>
@@ -6299,7 +6079,7 @@
           <a:bodyPr wrap="square" lIns="0" tIns="0" rIns="0" bIns="0" rtlCol="0" anchor="ctr"/>
           <a:lstStyle/>
           <a:p>
-            <a:pPr indent="0" marL="0">
+            <a:pPr marL="0" indent="0">
               <a:buNone/>
             </a:pPr>
             <a:r>
@@ -6338,7 +6118,7 @@
           <a:bodyPr wrap="square" lIns="508" tIns="508" rIns="508" bIns="508" rtlCol="0" anchor="t"/>
           <a:lstStyle/>
           <a:p>
-            <a:pPr indent="0" marL="0">
+            <a:pPr marL="0" indent="0">
               <a:buNone/>
             </a:pPr>
             <a:r>
@@ -6377,7 +6157,7 @@
           <a:bodyPr wrap="square" lIns="0" tIns="0" rIns="0" bIns="0" rtlCol="0" anchor="ctr"/>
           <a:lstStyle/>
           <a:p>
-            <a:pPr algn="ctr" indent="0" marL="0">
+            <a:pPr marL="0" indent="0" algn="ctr">
               <a:buNone/>
             </a:pPr>
             <a:r>
@@ -6397,7 +6177,7 @@
       </p:sp>
       <p:sp>
         <p:nvSpPr>
-          <p:cNvPr id="25" name="Slide Number Placeholder 0"/>
+          <p:cNvPr id="29" name="Slide Number Placeholder 0"/>
           <p:cNvSpPr>
             <a:spLocks noGrp="1"/>
           </p:cNvSpPr>
@@ -6415,7 +6195,7 @@
           </a:prstGeom>
           <a:extLst>
             <a:ext uri="{C572A759-6A51-4108-AA02-DFA0A04FC94B}">
-              <ma14:wrappingTextBoxFlag xmlns:ma14="http://schemas.microsoft.com/office/mac/drawingml/2011/main" val="0"/>
+              <ma14:wrappingTextBoxFlag xmlns:ma14="http://schemas.microsoft.com/office/mac/drawingml/2011/main" xmlns="" val="0"/>
             </a:ext>
           </a:extLst>
         </p:spPr>
@@ -6433,7 +6213,7 @@
           <a:p>
             <a:pPr algn="l"/>
             <a:fld id="{F7021451-1387-4CA6-816F-3879F97B5CBC}" type="slidenum">
-              <a:rPr b="0" lang="en-US"/>
+              <a:rPr lang="en-US" b="0"/>
               <a:t>7</a:t>
             </a:fld>
             <a:endParaRPr lang="en-US"/>
@@ -6456,6 +6236,7 @@
         <a:solidFill>
           <a:srgbClr val="071B31"/>
         </a:solidFill>
+        <a:effectLst/>
       </p:bgPr>
     </p:bg>
     <p:spTree>
@@ -6493,7 +6274,7 @@
           <a:bodyPr wrap="square" lIns="0" tIns="0" rIns="0" bIns="0" rtlCol="0" anchor="ctr"/>
           <a:lstStyle/>
           <a:p>
-            <a:pPr indent="0" marL="0">
+            <a:pPr marL="0" indent="0">
               <a:buNone/>
             </a:pPr>
             <a:r>
@@ -6532,7 +6313,7 @@
           <a:bodyPr wrap="square" lIns="0" tIns="0" rIns="0" bIns="0" rtlCol="0" anchor="ctr"/>
           <a:lstStyle/>
           <a:p>
-            <a:pPr indent="0" marL="0">
+            <a:pPr marL="0" indent="0">
               <a:buNone/>
             </a:pPr>
             <a:r>
@@ -6576,7 +6357,7 @@
             <a:prstDash val="solid"/>
           </a:ln>
           <a:effectLst>
-            <a:outerShdw sx="100000" sy="100000" kx="0" ky="0" algn="bl" rotWithShape="0" blurRad="25400" dist="50800" dir="2700000">
+            <a:outerShdw blurRad="25400" dist="50800" dir="2700000" algn="bl" rotWithShape="0">
               <a:srgbClr val="7A90A2">
                 <a:alpha val="13000"/>
               </a:srgbClr>
@@ -6632,7 +6413,7 @@
           <a:bodyPr wrap="square" lIns="0" tIns="0" rIns="0" bIns="0" rtlCol="0" anchor="ctr"/>
           <a:lstStyle/>
           <a:p>
-            <a:pPr indent="0" marL="0">
+            <a:pPr marL="0" indent="0">
               <a:buNone/>
             </a:pPr>
             <a:r>
@@ -6671,7 +6452,7 @@
           <a:bodyPr wrap="square" lIns="508" tIns="508" rIns="508" bIns="508" rtlCol="0" anchor="t"/>
           <a:lstStyle/>
           <a:p>
-            <a:pPr indent="0" marL="0">
+            <a:pPr marL="0" indent="0">
               <a:buNone/>
             </a:pPr>
             <a:r>
@@ -6715,7 +6496,7 @@
             <a:prstDash val="solid"/>
           </a:ln>
           <a:effectLst>
-            <a:outerShdw sx="100000" sy="100000" kx="0" ky="0" algn="bl" rotWithShape="0" blurRad="25400" dist="50800" dir="2700000">
+            <a:outerShdw blurRad="25400" dist="50800" dir="2700000" algn="bl" rotWithShape="0">
               <a:srgbClr val="7A90A2">
                 <a:alpha val="13000"/>
               </a:srgbClr>
@@ -6771,7 +6552,7 @@
           <a:bodyPr wrap="square" lIns="0" tIns="0" rIns="0" bIns="0" rtlCol="0" anchor="ctr"/>
           <a:lstStyle/>
           <a:p>
-            <a:pPr indent="0" marL="0">
+            <a:pPr marL="0" indent="0">
               <a:buNone/>
             </a:pPr>
             <a:r>
@@ -6810,7 +6591,7 @@
           <a:bodyPr wrap="square" lIns="508" tIns="508" rIns="508" bIns="508" rtlCol="0" anchor="t"/>
           <a:lstStyle/>
           <a:p>
-            <a:pPr indent="0" marL="0">
+            <a:pPr marL="0" indent="0">
               <a:buNone/>
             </a:pPr>
             <a:r>
@@ -6854,7 +6635,7 @@
             <a:prstDash val="solid"/>
           </a:ln>
           <a:effectLst>
-            <a:outerShdw sx="100000" sy="100000" kx="0" ky="0" algn="bl" rotWithShape="0" blurRad="25400" dist="50800" dir="2700000">
+            <a:outerShdw blurRad="25400" dist="50800" dir="2700000" algn="bl" rotWithShape="0">
               <a:srgbClr val="7A90A2">
                 <a:alpha val="13000"/>
               </a:srgbClr>
@@ -6910,7 +6691,7 @@
           <a:bodyPr wrap="square" lIns="0" tIns="0" rIns="0" bIns="0" rtlCol="0" anchor="ctr"/>
           <a:lstStyle/>
           <a:p>
-            <a:pPr indent="0" marL="0">
+            <a:pPr marL="0" indent="0">
               <a:buNone/>
             </a:pPr>
             <a:r>
@@ -6949,7 +6730,7 @@
           <a:bodyPr wrap="square" lIns="508" tIns="508" rIns="508" bIns="508" rtlCol="0" anchor="t"/>
           <a:lstStyle/>
           <a:p>
-            <a:pPr indent="0" marL="0">
+            <a:pPr marL="0" indent="0">
               <a:buNone/>
             </a:pPr>
             <a:r>
@@ -6988,7 +6769,7 @@
           <a:bodyPr wrap="square" lIns="0" tIns="0" rIns="0" bIns="0" rtlCol="0" anchor="ctr"/>
           <a:lstStyle/>
           <a:p>
-            <a:pPr indent="0" marL="0">
+            <a:pPr marL="0" indent="0">
               <a:buNone/>
             </a:pPr>
             <a:r>
@@ -7027,7 +6808,7 @@
           <a:bodyPr wrap="square" lIns="0" tIns="0" rIns="0" bIns="0" rtlCol="0" anchor="ctr"/>
           <a:lstStyle/>
           <a:p>
-            <a:pPr algn="r" indent="0" marL="0">
+            <a:pPr marL="0" indent="0" algn="r">
               <a:buNone/>
             </a:pPr>
             <a:r>
@@ -7346,4 +7127,299 @@
     </a:ext>
   </a:extLst>
 </a:theme>
+</file>
+
+<file path=ppt/theme/theme2.xml><?xml version="1.0" encoding="utf-8"?>
+<a:theme xmlns:a="http://schemas.openxmlformats.org/drawingml/2006/main" name="Office Theme">
+  <a:themeElements>
+    <a:clrScheme name="Office">
+      <a:dk1>
+        <a:sysClr val="windowText" lastClr="000000"/>
+      </a:dk1>
+      <a:lt1>
+        <a:sysClr val="window" lastClr="FFFFFF"/>
+      </a:lt1>
+      <a:dk2>
+        <a:srgbClr val="44546A"/>
+      </a:dk2>
+      <a:lt2>
+        <a:srgbClr val="E7E6E6"/>
+      </a:lt2>
+      <a:accent1>
+        <a:srgbClr val="4472C4"/>
+      </a:accent1>
+      <a:accent2>
+        <a:srgbClr val="ED7D31"/>
+      </a:accent2>
+      <a:accent3>
+        <a:srgbClr val="A5A5A5"/>
+      </a:accent3>
+      <a:accent4>
+        <a:srgbClr val="FFC000"/>
+      </a:accent4>
+      <a:accent5>
+        <a:srgbClr val="5B9BD5"/>
+      </a:accent5>
+      <a:accent6>
+        <a:srgbClr val="70AD47"/>
+      </a:accent6>
+      <a:hlink>
+        <a:srgbClr val="0563C1"/>
+      </a:hlink>
+      <a:folHlink>
+        <a:srgbClr val="954F72"/>
+      </a:folHlink>
+    </a:clrScheme>
+    <a:fontScheme name="Office">
+      <a:majorFont>
+        <a:latin typeface="Calibri Light" panose="020F0302020204030204"/>
+        <a:ea typeface=""/>
+        <a:cs typeface=""/>
+        <a:font script="Jpan" typeface="游ゴシック Light"/>
+        <a:font script="Hang" typeface="맑은 고딕"/>
+        <a:font script="Hans" typeface="等线 Light"/>
+        <a:font script="Hant" typeface="新細明體"/>
+        <a:font script="Arab" typeface="Times New Roman"/>
+        <a:font script="Hebr" typeface="Times New Roman"/>
+        <a:font script="Thai" typeface="Angsana New"/>
+        <a:font script="Ethi" typeface="Nyala"/>
+        <a:font script="Beng" typeface="Vrinda"/>
+        <a:font script="Gujr" typeface="Shruti"/>
+        <a:font script="Khmr" typeface="MoolBoran"/>
+        <a:font script="Knda" typeface="Tunga"/>
+        <a:font script="Guru" typeface="Raavi"/>
+        <a:font script="Cans" typeface="Euphemia"/>
+        <a:font script="Cher" typeface="Plantagenet Cherokee"/>
+        <a:font script="Yiii" typeface="Microsoft Yi Baiti"/>
+        <a:font script="Tibt" typeface="Microsoft Himalaya"/>
+        <a:font script="Thaa" typeface="MV Boli"/>
+        <a:font script="Deva" typeface="Mangal"/>
+        <a:font script="Telu" typeface="Gautami"/>
+        <a:font script="Taml" typeface="Latha"/>
+        <a:font script="Syrc" typeface="Estrangelo Edessa"/>
+        <a:font script="Orya" typeface="Kalinga"/>
+        <a:font script="Mlym" typeface="Kartika"/>
+        <a:font script="Laoo" typeface="DokChampa"/>
+        <a:font script="Sinh" typeface="Iskoola Pota"/>
+        <a:font script="Mong" typeface="Mongolian Baiti"/>
+        <a:font script="Viet" typeface="Times New Roman"/>
+        <a:font script="Uigh" typeface="Microsoft Uighur"/>
+        <a:font script="Geor" typeface="Sylfaen"/>
+        <a:font script="Armn" typeface="Arial"/>
+        <a:font script="Bugi" typeface="Leelawadee UI"/>
+        <a:font script="Bopo" typeface="Microsoft JhengHei"/>
+        <a:font script="Java" typeface="Javanese Text"/>
+        <a:font script="Lisu" typeface="Segoe UI"/>
+        <a:font script="Mymr" typeface="Myanmar Text"/>
+        <a:font script="Nkoo" typeface="Ebrima"/>
+        <a:font script="Olck" typeface="Nirmala UI"/>
+        <a:font script="Osma" typeface="Ebrima"/>
+        <a:font script="Phag" typeface="Phagspa"/>
+        <a:font script="Syrn" typeface="Estrangelo Edessa"/>
+        <a:font script="Syrj" typeface="Estrangelo Edessa"/>
+        <a:font script="Syre" typeface="Estrangelo Edessa"/>
+        <a:font script="Sora" typeface="Nirmala UI"/>
+        <a:font script="Tale" typeface="Microsoft Tai Le"/>
+        <a:font script="Talu" typeface="Microsoft New Tai Lue"/>
+        <a:font script="Tfng" typeface="Ebrima"/>
+      </a:majorFont>
+      <a:minorFont>
+        <a:latin typeface="Calibri" panose="020F0502020204030204"/>
+        <a:ea typeface=""/>
+        <a:cs typeface=""/>
+        <a:font script="Jpan" typeface="游ゴシック"/>
+        <a:font script="Hang" typeface="맑은 고딕"/>
+        <a:font script="Hans" typeface="等线"/>
+        <a:font script="Hant" typeface="新細明體"/>
+        <a:font script="Arab" typeface="Arial"/>
+        <a:font script="Hebr" typeface="Arial"/>
+        <a:font script="Thai" typeface="Cordia New"/>
+        <a:font script="Ethi" typeface="Nyala"/>
+        <a:font script="Beng" typeface="Vrinda"/>
+        <a:font script="Gujr" typeface="Shruti"/>
+        <a:font script="Khmr" typeface="DaunPenh"/>
+        <a:font script="Knda" typeface="Tunga"/>
+        <a:font script="Guru" typeface="Raavi"/>
+        <a:font script="Cans" typeface="Euphemia"/>
+        <a:font script="Cher" typeface="Plantagenet Cherokee"/>
+        <a:font script="Yiii" typeface="Microsoft Yi Baiti"/>
+        <a:font script="Tibt" typeface="Microsoft Himalaya"/>
+        <a:font script="Thaa" typeface="MV Boli"/>
+        <a:font script="Deva" typeface="Mangal"/>
+        <a:font script="Telu" typeface="Gautami"/>
+        <a:font script="Taml" typeface="Latha"/>
+        <a:font script="Syrc" typeface="Estrangelo Edessa"/>
+        <a:font script="Orya" typeface="Kalinga"/>
+        <a:font script="Mlym" typeface="Kartika"/>
+        <a:font script="Laoo" typeface="DokChampa"/>
+        <a:font script="Sinh" typeface="Iskoola Pota"/>
+        <a:font script="Mong" typeface="Mongolian Baiti"/>
+        <a:font script="Viet" typeface="Arial"/>
+        <a:font script="Uigh" typeface="Microsoft Uighur"/>
+        <a:font script="Geor" typeface="Sylfaen"/>
+        <a:font script="Armn" typeface="Arial"/>
+        <a:font script="Bugi" typeface="Leelawadee UI"/>
+        <a:font script="Bopo" typeface="Microsoft JhengHei"/>
+        <a:font script="Java" typeface="Javanese Text"/>
+        <a:font script="Lisu" typeface="Segoe UI"/>
+        <a:font script="Mymr" typeface="Myanmar Text"/>
+        <a:font script="Nkoo" typeface="Ebrima"/>
+        <a:font script="Olck" typeface="Nirmala UI"/>
+        <a:font script="Osma" typeface="Ebrima"/>
+        <a:font script="Phag" typeface="Phagspa"/>
+        <a:font script="Syrn" typeface="Estrangelo Edessa"/>
+        <a:font script="Syrj" typeface="Estrangelo Edessa"/>
+        <a:font script="Syre" typeface="Estrangelo Edessa"/>
+        <a:font script="Sora" typeface="Nirmala UI"/>
+        <a:font script="Tale" typeface="Microsoft Tai Le"/>
+        <a:font script="Talu" typeface="Microsoft New Tai Lue"/>
+        <a:font script="Tfng" typeface="Ebrima"/>
+      </a:minorFont>
+    </a:fontScheme>
+    <a:fmtScheme name="Office">
+      <a:fillStyleLst>
+        <a:solidFill>
+          <a:schemeClr val="phClr"/>
+        </a:solidFill>
+        <a:gradFill rotWithShape="1">
+          <a:gsLst>
+            <a:gs pos="0">
+              <a:schemeClr val="phClr">
+                <a:lumMod val="110000"/>
+                <a:satMod val="105000"/>
+                <a:tint val="67000"/>
+              </a:schemeClr>
+            </a:gs>
+            <a:gs pos="50000">
+              <a:schemeClr val="phClr">
+                <a:lumMod val="105000"/>
+                <a:satMod val="103000"/>
+                <a:tint val="73000"/>
+              </a:schemeClr>
+            </a:gs>
+            <a:gs pos="100000">
+              <a:schemeClr val="phClr">
+                <a:lumMod val="105000"/>
+                <a:satMod val="109000"/>
+                <a:tint val="81000"/>
+              </a:schemeClr>
+            </a:gs>
+          </a:gsLst>
+          <a:lin ang="5400000" scaled="0"/>
+        </a:gradFill>
+        <a:gradFill rotWithShape="1">
+          <a:gsLst>
+            <a:gs pos="0">
+              <a:schemeClr val="phClr">
+                <a:satMod val="103000"/>
+                <a:lumMod val="102000"/>
+                <a:tint val="94000"/>
+              </a:schemeClr>
+            </a:gs>
+            <a:gs pos="50000">
+              <a:schemeClr val="phClr">
+                <a:satMod val="110000"/>
+                <a:lumMod val="100000"/>
+                <a:shade val="100000"/>
+              </a:schemeClr>
+            </a:gs>
+            <a:gs pos="100000">
+              <a:schemeClr val="phClr">
+                <a:lumMod val="99000"/>
+                <a:satMod val="120000"/>
+                <a:shade val="78000"/>
+              </a:schemeClr>
+            </a:gs>
+          </a:gsLst>
+          <a:lin ang="5400000" scaled="0"/>
+        </a:gradFill>
+      </a:fillStyleLst>
+      <a:lnStyleLst>
+        <a:ln w="6350" cap="flat" cmpd="sng" algn="ctr">
+          <a:solidFill>
+            <a:schemeClr val="phClr"/>
+          </a:solidFill>
+          <a:prstDash val="solid"/>
+          <a:miter lim="800000"/>
+        </a:ln>
+        <a:ln w="12700" cap="flat" cmpd="sng" algn="ctr">
+          <a:solidFill>
+            <a:schemeClr val="phClr"/>
+          </a:solidFill>
+          <a:prstDash val="solid"/>
+          <a:miter lim="800000"/>
+        </a:ln>
+        <a:ln w="19050" cap="flat" cmpd="sng" algn="ctr">
+          <a:solidFill>
+            <a:schemeClr val="phClr"/>
+          </a:solidFill>
+          <a:prstDash val="solid"/>
+          <a:miter lim="800000"/>
+        </a:ln>
+      </a:lnStyleLst>
+      <a:effectStyleLst>
+        <a:effectStyle>
+          <a:effectLst/>
+        </a:effectStyle>
+        <a:effectStyle>
+          <a:effectLst/>
+        </a:effectStyle>
+        <a:effectStyle>
+          <a:effectLst>
+            <a:outerShdw blurRad="57150" dist="19050" dir="5400000" algn="ctr" rotWithShape="0">
+              <a:srgbClr val="000000">
+                <a:alpha val="63000"/>
+              </a:srgbClr>
+            </a:outerShdw>
+          </a:effectLst>
+        </a:effectStyle>
+      </a:effectStyleLst>
+      <a:bgFillStyleLst>
+        <a:solidFill>
+          <a:schemeClr val="phClr"/>
+        </a:solidFill>
+        <a:solidFill>
+          <a:schemeClr val="phClr">
+            <a:tint val="95000"/>
+            <a:satMod val="170000"/>
+          </a:schemeClr>
+        </a:solidFill>
+        <a:gradFill rotWithShape="1">
+          <a:gsLst>
+            <a:gs pos="0">
+              <a:schemeClr val="phClr">
+                <a:tint val="93000"/>
+                <a:satMod val="150000"/>
+                <a:shade val="98000"/>
+                <a:lumMod val="102000"/>
+              </a:schemeClr>
+            </a:gs>
+            <a:gs pos="50000">
+              <a:schemeClr val="phClr">
+                <a:tint val="98000"/>
+                <a:satMod val="130000"/>
+                <a:shade val="90000"/>
+                <a:lumMod val="103000"/>
+              </a:schemeClr>
+            </a:gs>
+            <a:gs pos="100000">
+              <a:schemeClr val="phClr">
+                <a:shade val="63000"/>
+                <a:satMod val="120000"/>
+              </a:schemeClr>
+            </a:gs>
+          </a:gsLst>
+          <a:lin ang="5400000" scaled="0"/>
+        </a:gradFill>
+      </a:bgFillStyleLst>
+    </a:fmtScheme>
+  </a:themeElements>
+  <a:objectDefaults/>
+  <a:extraClrSchemeLst/>
+  <a:extLst>
+    <a:ext uri="{05A4C25C-085E-4340-85A3-A5531E510DB2}">
+      <thm15:themeFamily xmlns:thm15="http://schemas.microsoft.com/office/thememl/2012/main" name="Office Theme" id="{62F939B6-93AF-4DB8-9C6B-D6C7DFDC589F}" vid="{4A3C46E8-61CC-4603-A589-7422A47A8E4A}"/>
+    </a:ext>
+  </a:extLst>
+</a:theme>
 </file>
</xml_diff>